<commit_message>
docs: restyle chatbot diagrams to match the deck theme, add logo
Redraw the 5 flow diagrams in the deck palette (red, deep red, tint,
ink) with larger text and fewer words, add the X Fitness logo to the
title slide and report cover, restart numbered lists at 1 in the report,
and drop the generated PDFs from docs/.

Co-Authored-By: Claude Opus 5.5 <noreply@anthropic.com>
</commit_message>
<xml_diff>
--- a/docs/XFitness-Chatbot_Presentation_v1.0.pptx
+++ b/docs/XFitness-Chatbot_Presentation_v1.0.pptx
@@ -3322,6 +3322,30 @@
           </a:p>
         </p:txBody>
       </p:sp>
+      <p:pic>
+        <p:nvPicPr>
+          <p:cNvPr id="7" name="Picture 6" descr="x-fitness-logo-on-light.png"/>
+          <p:cNvPicPr>
+            <a:picLocks noChangeAspect="1"/>
+          </p:cNvPicPr>
+          <p:nvPr/>
+        </p:nvPicPr>
+        <p:blipFill>
+          <a:blip r:embed="rId2"/>
+          <a:stretch>
+            <a:fillRect/>
+          </a:stretch>
+        </p:blipFill>
+        <p:spPr>
+          <a:xfrm>
+            <a:off x="822960" y="960120"/>
+            <a:ext cx="2703981" cy="566928"/>
+          </a:xfrm>
+          <a:prstGeom prst="rect">
+            <a:avLst/>
+          </a:prstGeom>
+        </p:spPr>
+      </p:pic>
     </p:spTree>
   </p:cSld>
   <p:clrMapOvr>
@@ -4650,8 +4674,8 @@
         </p:blipFill>
         <p:spPr>
           <a:xfrm>
-            <a:off x="1641078" y="1508760"/>
-            <a:ext cx="8909538" cy="4343400"/>
+            <a:off x="822960" y="1508760"/>
+            <a:ext cx="10545775" cy="3691021"/>
           </a:xfrm>
           <a:prstGeom prst="rect">
             <a:avLst/>
@@ -5578,8 +5602,8 @@
         </p:blipFill>
         <p:spPr>
           <a:xfrm>
-            <a:off x="1889164" y="1508760"/>
-            <a:ext cx="8413366" cy="4343400"/>
+            <a:off x="978439" y="1508760"/>
+            <a:ext cx="10234816" cy="4343400"/>
           </a:xfrm>
           <a:prstGeom prst="rect">
             <a:avLst/>
@@ -5861,8 +5885,8 @@
         </p:blipFill>
         <p:spPr>
           <a:xfrm>
-            <a:off x="1229293" y="1508760"/>
-            <a:ext cx="9733109" cy="4343400"/>
+            <a:off x="822960" y="1508760"/>
+            <a:ext cx="10545775" cy="3763523"/>
           </a:xfrm>
           <a:prstGeom prst="rect">
             <a:avLst/>
@@ -6144,8 +6168,8 @@
         </p:blipFill>
         <p:spPr>
           <a:xfrm>
-            <a:off x="948114" y="1508760"/>
-            <a:ext cx="10295467" cy="4343400"/>
+            <a:off x="822960" y="1508760"/>
+            <a:ext cx="10545775" cy="3157141"/>
           </a:xfrm>
           <a:prstGeom prst="rect">
             <a:avLst/>
@@ -6427,8 +6451,8 @@
         </p:blipFill>
         <p:spPr>
           <a:xfrm>
-            <a:off x="1355438" y="1508760"/>
-            <a:ext cx="9480819" cy="4343400"/>
+            <a:off x="822960" y="1508760"/>
+            <a:ext cx="10545775" cy="3269190"/>
           </a:xfrm>
           <a:prstGeom prst="rect">
             <a:avLst/>

</xml_diff>